<commit_message>
Update figures for L_Q-L_C relationship
</commit_message>
<xml_diff>
--- a/figures/L_Q-L_C-relationship.pptx
+++ b/figures/L_Q-L_C-relationship.pptx
@@ -261,7 +261,7 @@
           <a:p>
             <a:fld id="{3856C8F1-7A7E-ED4D-B118-346949A716F4}" type="datetimeFigureOut">
               <a:rPr lang="en-US" smtClean="0"/>
-              <a:t>12/19/25</a:t>
+              <a:t>3/11/26</a:t>
             </a:fld>
             <a:endParaRPr lang="en-US"/>
           </a:p>
@@ -461,7 +461,7 @@
           <a:p>
             <a:fld id="{3856C8F1-7A7E-ED4D-B118-346949A716F4}" type="datetimeFigureOut">
               <a:rPr lang="en-US" smtClean="0"/>
-              <a:t>12/19/25</a:t>
+              <a:t>3/11/26</a:t>
             </a:fld>
             <a:endParaRPr lang="en-US"/>
           </a:p>
@@ -671,7 +671,7 @@
           <a:p>
             <a:fld id="{3856C8F1-7A7E-ED4D-B118-346949A716F4}" type="datetimeFigureOut">
               <a:rPr lang="en-US" smtClean="0"/>
-              <a:t>12/19/25</a:t>
+              <a:t>3/11/26</a:t>
             </a:fld>
             <a:endParaRPr lang="en-US"/>
           </a:p>
@@ -871,7 +871,7 @@
           <a:p>
             <a:fld id="{3856C8F1-7A7E-ED4D-B118-346949A716F4}" type="datetimeFigureOut">
               <a:rPr lang="en-US" smtClean="0"/>
-              <a:t>12/19/25</a:t>
+              <a:t>3/11/26</a:t>
             </a:fld>
             <a:endParaRPr lang="en-US"/>
           </a:p>
@@ -1147,7 +1147,7 @@
           <a:p>
             <a:fld id="{3856C8F1-7A7E-ED4D-B118-346949A716F4}" type="datetimeFigureOut">
               <a:rPr lang="en-US" smtClean="0"/>
-              <a:t>12/19/25</a:t>
+              <a:t>3/11/26</a:t>
             </a:fld>
             <a:endParaRPr lang="en-US"/>
           </a:p>
@@ -1415,7 +1415,7 @@
           <a:p>
             <a:fld id="{3856C8F1-7A7E-ED4D-B118-346949A716F4}" type="datetimeFigureOut">
               <a:rPr lang="en-US" smtClean="0"/>
-              <a:t>12/19/25</a:t>
+              <a:t>3/11/26</a:t>
             </a:fld>
             <a:endParaRPr lang="en-US"/>
           </a:p>
@@ -1830,7 +1830,7 @@
           <a:p>
             <a:fld id="{3856C8F1-7A7E-ED4D-B118-346949A716F4}" type="datetimeFigureOut">
               <a:rPr lang="en-US" smtClean="0"/>
-              <a:t>12/19/25</a:t>
+              <a:t>3/11/26</a:t>
             </a:fld>
             <a:endParaRPr lang="en-US"/>
           </a:p>
@@ -1972,7 +1972,7 @@
           <a:p>
             <a:fld id="{3856C8F1-7A7E-ED4D-B118-346949A716F4}" type="datetimeFigureOut">
               <a:rPr lang="en-US" smtClean="0"/>
-              <a:t>12/19/25</a:t>
+              <a:t>3/11/26</a:t>
             </a:fld>
             <a:endParaRPr lang="en-US"/>
           </a:p>
@@ -2085,7 +2085,7 @@
           <a:p>
             <a:fld id="{3856C8F1-7A7E-ED4D-B118-346949A716F4}" type="datetimeFigureOut">
               <a:rPr lang="en-US" smtClean="0"/>
-              <a:t>12/19/25</a:t>
+              <a:t>3/11/26</a:t>
             </a:fld>
             <a:endParaRPr lang="en-US"/>
           </a:p>
@@ -2398,7 +2398,7 @@
           <a:p>
             <a:fld id="{3856C8F1-7A7E-ED4D-B118-346949A716F4}" type="datetimeFigureOut">
               <a:rPr lang="en-US" smtClean="0"/>
-              <a:t>12/19/25</a:t>
+              <a:t>3/11/26</a:t>
             </a:fld>
             <a:endParaRPr lang="en-US"/>
           </a:p>
@@ -2687,7 +2687,7 @@
           <a:p>
             <a:fld id="{3856C8F1-7A7E-ED4D-B118-346949A716F4}" type="datetimeFigureOut">
               <a:rPr lang="en-US" smtClean="0"/>
-              <a:t>12/19/25</a:t>
+              <a:t>3/11/26</a:t>
             </a:fld>
             <a:endParaRPr lang="en-US"/>
           </a:p>
@@ -2930,7 +2930,7 @@
           <a:p>
             <a:fld id="{3856C8F1-7A7E-ED4D-B118-346949A716F4}" type="datetimeFigureOut">
               <a:rPr lang="en-US" smtClean="0"/>
-              <a:t>12/19/25</a:t>
+              <a:t>3/11/26</a:t>
             </a:fld>
             <a:endParaRPr lang="en-US"/>
           </a:p>
@@ -5647,6 +5647,148 @@
           </a:p>
         </p:txBody>
       </p:sp>
+      <p:cxnSp>
+        <p:nvCxnSpPr>
+          <p:cNvPr id="2" name="Straight Arrow Connector 1">
+            <a:extLst>
+              <a:ext uri="{FF2B5EF4-FFF2-40B4-BE49-F238E27FC236}">
+                <a16:creationId xmlns:a16="http://schemas.microsoft.com/office/drawing/2014/main" id="{4BFE0C08-A161-00AD-AA51-A1833D3A03A6}"/>
+              </a:ext>
+            </a:extLst>
+          </p:cNvPr>
+          <p:cNvCxnSpPr>
+            <a:cxnSpLocks/>
+          </p:cNvCxnSpPr>
+          <p:nvPr/>
+        </p:nvCxnSpPr>
+        <p:spPr>
+          <a:xfrm flipH="1" flipV="1">
+            <a:off x="4600616" y="2317932"/>
+            <a:ext cx="1068697" cy="1212103"/>
+          </a:xfrm>
+          <a:prstGeom prst="straightConnector1">
+            <a:avLst/>
+          </a:prstGeom>
+          <a:ln cmpd="sng">
+            <a:solidFill>
+              <a:schemeClr val="tx1"/>
+            </a:solidFill>
+            <a:prstDash val="lgDashDotDot"/>
+            <a:tailEnd type="none"/>
+          </a:ln>
+        </p:spPr>
+        <p:style>
+          <a:lnRef idx="1">
+            <a:schemeClr val="accent1"/>
+          </a:lnRef>
+          <a:fillRef idx="0">
+            <a:schemeClr val="accent1"/>
+          </a:fillRef>
+          <a:effectRef idx="0">
+            <a:schemeClr val="accent1"/>
+          </a:effectRef>
+          <a:fontRef idx="minor">
+            <a:schemeClr val="tx1"/>
+          </a:fontRef>
+        </p:style>
+      </p:cxnSp>
+      <mc:AlternateContent xmlns:mc="http://schemas.openxmlformats.org/markup-compatibility/2006">
+        <mc:Choice xmlns:a14="http://schemas.microsoft.com/office/drawing/2010/main" Requires="a14">
+          <p:sp>
+            <p:nvSpPr>
+              <p:cNvPr id="18" name="TextBox 17">
+                <a:extLst>
+                  <a:ext uri="{FF2B5EF4-FFF2-40B4-BE49-F238E27FC236}">
+                    <a16:creationId xmlns:a16="http://schemas.microsoft.com/office/drawing/2014/main" id="{B1C24871-1894-5F83-292B-E8E756046F59}"/>
+                  </a:ext>
+                </a:extLst>
+              </p:cNvPr>
+              <p:cNvSpPr txBox="1"/>
+              <p:nvPr/>
+            </p:nvSpPr>
+            <p:spPr>
+              <a:xfrm>
+                <a:off x="4785919" y="2323295"/>
+                <a:ext cx="893889" cy="370230"/>
+              </a:xfrm>
+              <a:prstGeom prst="rect">
+                <a:avLst/>
+              </a:prstGeom>
+              <a:noFill/>
+            </p:spPr>
+            <p:txBody>
+              <a:bodyPr wrap="square">
+                <a:spAutoFit/>
+              </a:bodyPr>
+              <a:lstStyle/>
+              <a:p>
+                <a:pPr/>
+                <a14:m>
+                  <m:oMathPara xmlns:m="http://schemas.openxmlformats.org/officeDocument/2006/math">
+                    <m:oMathParaPr>
+                      <m:jc m:val="centerGroup"/>
+                    </m:oMathParaPr>
+                    <m:oMath xmlns:m="http://schemas.openxmlformats.org/officeDocument/2006/math">
+                      <m:r>
+                        <a:rPr lang="en-US" i="1" smtClean="0">
+                          <a:latin typeface="Cambria Math" panose="02040503050406030204" pitchFamily="18" charset="0"/>
+                          <a:cs typeface="Times New Roman" panose="02020603050405020304" pitchFamily="18" charset="0"/>
+                        </a:rPr>
+                        <m:t>…</m:t>
+                      </m:r>
+                    </m:oMath>
+                  </m:oMathPara>
+                </a14:m>
+                <a:endParaRPr lang="en-US" dirty="0"/>
+              </a:p>
+            </p:txBody>
+          </p:sp>
+        </mc:Choice>
+        <mc:Fallback>
+          <p:sp>
+            <p:nvSpPr>
+              <p:cNvPr id="18" name="TextBox 17">
+                <a:extLst>
+                  <a:ext uri="{FF2B5EF4-FFF2-40B4-BE49-F238E27FC236}">
+                    <a16:creationId xmlns:a16="http://schemas.microsoft.com/office/drawing/2014/main" id="{B1C24871-1894-5F83-292B-E8E756046F59}"/>
+                  </a:ext>
+                </a:extLst>
+              </p:cNvPr>
+              <p:cNvSpPr txBox="1">
+                <a:spLocks noRot="1" noChangeAspect="1" noMove="1" noResize="1" noEditPoints="1" noAdjustHandles="1" noChangeArrowheads="1" noChangeShapeType="1" noTextEdit="1"/>
+              </p:cNvSpPr>
+              <p:nvPr/>
+            </p:nvSpPr>
+            <p:spPr>
+              <a:xfrm>
+                <a:off x="4785919" y="2323295"/>
+                <a:ext cx="893889" cy="370230"/>
+              </a:xfrm>
+              <a:prstGeom prst="rect">
+                <a:avLst/>
+              </a:prstGeom>
+              <a:blipFill>
+                <a:blip r:embed="rId19"/>
+                <a:stretch>
+                  <a:fillRect/>
+                </a:stretch>
+              </a:blipFill>
+            </p:spPr>
+            <p:txBody>
+              <a:bodyPr/>
+              <a:lstStyle/>
+              <a:p>
+                <a:r>
+                  <a:rPr lang="en-US">
+                    <a:noFill/>
+                  </a:rPr>
+                  <a:t> </a:t>
+                </a:r>
+              </a:p>
+            </p:txBody>
+          </p:sp>
+        </mc:Fallback>
+      </mc:AlternateContent>
     </p:spTree>
     <p:extLst>
       <p:ext uri="{BB962C8B-B14F-4D97-AF65-F5344CB8AC3E}">

</xml_diff>